<commit_message>
Sync updated demo and dashboard files
Co-authored-by: Copilot <223556219+Copilot@users.noreply.github.com>
</commit_message>
<xml_diff>
--- a/presentation/NephroTwin_AI_Pitch_Deck.pptx
+++ b/presentation/NephroTwin_AI_Pitch_Deck.pptx
@@ -7173,7 +7173,7 @@
       </p:sp>
       <p:pic>
         <p:nvPicPr>
-          <p:cNvPr id="22" name="Picture 21" descr="ravi_baseline_vs_heatwave.png"/>
+          <p:cNvPr id="22" name="Picture 21" descr="ravi_demo.png"/>
           <p:cNvPicPr>
             <a:picLocks noChangeAspect="1"/>
           </p:cNvPicPr>
@@ -7187,8 +7187,8 @@
         </p:blipFill>
         <p:spPr>
           <a:xfrm>
-            <a:off x="813816" y="1874519"/>
-            <a:ext cx="5162204" cy="3154680"/>
+            <a:off x="813816" y="1828800"/>
+            <a:ext cx="5464322" cy="3017520"/>
           </a:xfrm>
           <a:prstGeom prst="rect">
             <a:avLst/>
@@ -7197,7 +7197,7 @@
       </p:pic>
       <p:pic>
         <p:nvPicPr>
-          <p:cNvPr id="23" name="Picture 22" descr="real_roc_comparison.png"/>
+          <p:cNvPr id="23" name="Picture 22" descr="real_data.png"/>
           <p:cNvPicPr>
             <a:picLocks noChangeAspect="1"/>
           </p:cNvPicPr>
@@ -7211,8 +7211,8 @@
         </p:blipFill>
         <p:spPr>
           <a:xfrm>
-            <a:off x="6720840" y="1874519"/>
-            <a:ext cx="4301836" cy="3154680"/>
+            <a:off x="6355080" y="1828800"/>
+            <a:ext cx="5464322" cy="3017520"/>
           </a:xfrm>
           <a:prstGeom prst="rect">
             <a:avLst/>
@@ -7227,8 +7227,8 @@
         </p:nvSpPr>
         <p:spPr>
           <a:xfrm>
-            <a:off x="813816" y="5138928"/>
-            <a:ext cx="5669280" cy="822960"/>
+            <a:off x="813816" y="4983480"/>
+            <a:ext cx="5029200" cy="822960"/>
           </a:xfrm>
           <a:prstGeom prst="rect">
             <a:avLst/>
@@ -7248,7 +7248,7 @@
                 </a:solidFill>
                 <a:latin typeface="DM Sans"/>
               </a:rPr>
-              <a:t>Guided demo, step 5. The twin recomputes live: the same plan scores 4% (Green) at baseline and 55% with the synthetic heat-wave input. Shaded band = 10th to 90th percentile. Synthetic patient, demonstration input.</a:t>
+              <a:t>Ravi guided demo, step 5 (live app). The twin recomputes: the same plan scores 4% (Green) at baseline and 55% (Amber) with the synthetic heat-wave input. Synthetic patient, demonstration input.</a:t>
             </a:r>
           </a:p>
         </p:txBody>
@@ -7261,8 +7261,8 @@
         </p:nvSpPr>
         <p:spPr>
           <a:xfrm>
-            <a:off x="6720840" y="5138928"/>
-            <a:ext cx="4663440" cy="822960"/>
+            <a:off x="6355080" y="4983480"/>
+            <a:ext cx="5029200" cy="822960"/>
           </a:xfrm>
           <a:prstGeom prst="rect">
             <a:avLst/>
@@ -7282,7 +7282,7 @@
                 </a:solidFill>
                 <a:latin typeface="DM Sans"/>
               </a:rPr>
-              <a:t>Real-data validation (HEMOBP). The hybrid edges the standard model (0.871 vs 0.863) while adding physiology and what-if simulation; the twin alone trails. We report that openly.</a:t>
+              <a:t>Real-data validation page (live app). The hybrid edges the standard model (0.871 vs 0.863) while adding physiology and what-if simulation; the twin alone trails. We report that openly.</a:t>
             </a:r>
           </a:p>
         </p:txBody>

</xml_diff>